<commit_message>
Upgraded SIH 2026 Ideation PPT (OSCode_Decode_SIH_2026_Ideation_PPT_Updated.pptx) to include V2X 5G, 24GHz Radar, Iron Man AR HUD, 9-Simulation Grid, PyTorch DQN RL, and Academic Research Literature Gap Bridging without IEEE mention
</commit_message>
<xml_diff>
--- a/presentation/OSCode_Decode_SIH_2026_Ideation_PPT_Updated.pptx
+++ b/presentation/OSCode_Decode_SIH_2026_Ideation_PPT_Updated.pptx
@@ -4311,112 +4311,47 @@
           </a:bodyPr>
           <a:lstStyle/>
           <a:p>
-            <a:pPr>
-              <a:defRPr sz="1500" b="1">
-                <a:solidFill>
-                  <a:srgbClr val="000000"/>
-                </a:solidFill>
-                <a:latin typeface="Arial"/>
-              </a:defRPr>
-            </a:pPr>
             <a:r>
               <a:t>Who faces this issue?</a:t>
             </a:r>
           </a:p>
           <a:p>
-            <a:pPr>
-              <a:defRPr sz="1200">
-                <a:solidFill>
-                  <a:srgbClr val="505050"/>
-                </a:solidFill>
-                <a:latin typeface="Arial"/>
-              </a:defRPr>
-            </a:pPr>
-            <a:r>
-              <a:t>Daily commuters &amp; transport services, emergency services (ambulances), and smart city administrations.</a:t>
-            </a:r>
-            <a:br/>
-          </a:p>
-          <a:p>
-            <a:pPr>
-              <a:defRPr sz="1500" b="1">
-                <a:solidFill>
-                  <a:srgbClr val="000000"/>
-                </a:solidFill>
-                <a:latin typeface="Arial"/>
-              </a:defRPr>
-            </a:pPr>
+            <a:r>
+              <a:t>Daily commuters &amp; transport services, emergency services (ambulances), smart city traffic administrations, and connected autonomous vehicles (CAVs).</a:t>
+            </a:r>
+          </a:p>
+          <a:p/>
+          <a:p>
             <a:r>
               <a:t>What's the current gap in the system?</a:t>
             </a:r>
           </a:p>
           <a:p>
-            <a:pPr>
-              <a:defRPr sz="1200">
-                <a:solidFill>
-                  <a:srgbClr val="505050"/>
-                </a:solidFill>
-                <a:latin typeface="Arial"/>
-              </a:defRPr>
-            </a:pPr>
-            <a:r>
-              <a:t>Lack of lane-level traffic density awareness, static traffic lights, no spatiotemporal congestion forecasting, and no emergency vehicle signal overrides.</a:t>
-            </a:r>
-            <a:br/>
-          </a:p>
-          <a:p>
-            <a:pPr>
-              <a:defRPr sz="1500" b="1">
-                <a:solidFill>
-                  <a:srgbClr val="000000"/>
-                </a:solidFill>
-                <a:latin typeface="Arial"/>
-              </a:defRPr>
-            </a:pPr>
+            <a:r>
+              <a:t>Lack of lane-level traffic density awareness, static traffic light timers, no V2X (Vehicle-to-Everything) 5G communication, no 24GHz Doppler Radar fusion, no multi-scenario micro-simulation evaluation, no ANPR digital ticket issuance, and no acoustic siren preemption.</a:t>
+            </a:r>
+          </a:p>
+          <a:p/>
+          <a:p>
             <a:r>
               <a:t>How does your proposed solution fill that gap practically?</a:t>
             </a:r>
           </a:p>
           <a:p>
-            <a:pPr>
-              <a:defRPr sz="1200">
-                <a:solidFill>
-                  <a:srgbClr val="505050"/>
-                </a:solidFill>
-                <a:latin typeface="Arial"/>
-              </a:defRPr>
-            </a:pPr>
-            <a:r>
-              <a:t>Uses YOLO object classification and speed trackers to measure lane queues. Adjusts signals dynamically, clears routes for ambulances, and maps details on a 2D Digital Twin.</a:t>
-            </a:r>
-            <a:br/>
-          </a:p>
-          <a:p>
-            <a:pPr>
-              <a:defRPr sz="1500" b="1">
-                <a:solidFill>
-                  <a:srgbClr val="000000"/>
-                </a:solidFill>
-                <a:latin typeface="Arial"/>
-              </a:defRPr>
-            </a:pPr>
+            <a:r>
+              <a:t>Fills gaps by combining YOLOv26n vision with 24GHz Doppler Radar, C-V2X 5G GLOSA speed advisories (45 km/h), PyTorch Deep Q-Network (DQN) RL + CMU SURTRAC signal optimization, ANPR E-Challan digital ticketing, and a 9-Scenario Parallel Micro-Simulation Grid with Gold Ribbon Winner selection.</a:t>
+            </a:r>
+          </a:p>
+          <a:p/>
+          <a:p>
             <a:r>
               <a:t>If possible, mention if it connects to any existing schemes.</a:t>
             </a:r>
           </a:p>
           <a:p>
-            <a:pPr>
-              <a:defRPr sz="1200">
-                <a:solidFill>
-                  <a:srgbClr val="505050"/>
-                </a:solidFill>
-                <a:latin typeface="Arial"/>
-              </a:defRPr>
-            </a:pPr>
-            <a:r>
-              <a:t>Connects directly with the Smart Cities Mission (intelligent transport systems) and Digital India (localized edge computing solutions).</a:t>
-            </a:r>
-            <a:br/>
+            <a:r>
+              <a:t>Connects directly with the Smart Cities Mission (intelligent transport systems), Digital India (edge AI computing), and National Automotive Board V2X Connected Vehicle Initiatives.</a:t>
+            </a:r>
           </a:p>
         </p:txBody>
       </p:sp>
@@ -4674,97 +4609,71 @@
           </a:bodyPr>
           <a:lstStyle/>
           <a:p>
-            <a:pPr>
-              <a:defRPr sz="1500" b="1">
-                <a:solidFill>
-                  <a:srgbClr val="000000"/>
-                </a:solidFill>
-                <a:latin typeface="Arial"/>
-              </a:defRPr>
-            </a:pPr>
             <a:r>
               <a:t>What are you Building?</a:t>
             </a:r>
           </a:p>
           <a:p>
-            <a:pPr>
-              <a:defRPr sz="1200">
-                <a:solidFill>
-                  <a:srgbClr val="505050"/>
-                </a:solidFill>
-                <a:latin typeface="Arial"/>
-              </a:defRPr>
-            </a:pPr>
-            <a:r>
-              <a:t>TraffixAI is a localized, reactive AI Traffic Digital Twin. Using an edge-optimized YOLOv26n model, the system detects and tracks cars, trucks, motorcycles, and pedestrians lane-by-lane. It measures real-time queue densities and vehicle velocities to dynamically adjust signal durations. Crucially, the system offers Explainable AI (XAI) justifications to traffic operators and calculates real-time carbon offsets (CO2 saved) based on reduced vehicle idling times.</a:t>
-            </a:r>
-            <a:br/>
-          </a:p>
-          <a:p>
-            <a:pPr>
-              <a:defRPr sz="1500" b="1">
-                <a:solidFill>
-                  <a:srgbClr val="000000"/>
-                </a:solidFill>
-                <a:latin typeface="Arial"/>
-              </a:defRPr>
-            </a:pPr>
-            <a:r>
-              <a:t>What are the 3-4 Key Features?</a:t>
-            </a:r>
-          </a:p>
-          <a:p>
-            <a:pPr>
-              <a:defRPr sz="1200">
-                <a:solidFill>
-                  <a:srgbClr val="505050"/>
-                </a:solidFill>
-                <a:latin typeface="Arial"/>
-              </a:defRPr>
-            </a:pPr>
-            <a:r>
-              <a:t>1. Real-Time 2D Spatial Digital Twin Map</a:t>
-            </a:r>
-            <a:br/>
-            <a:r>
-              <a:t>2. Adaptive Lane Signaling &amp; Emergency Override</a:t>
-            </a:r>
-            <a:br/>
-            <a:r>
-              <a:t>3. Explainable AI (XAI) Decisional Log</a:t>
-            </a:r>
-            <a:br/>
-            <a:r>
-              <a:t>4. Eco-Impact Carbon Offset (CO2 Saved) Tracker</a:t>
-            </a:r>
-            <a:br/>
-          </a:p>
-          <a:p>
-            <a:pPr>
-              <a:defRPr sz="1500" b="1">
-                <a:solidFill>
-                  <a:srgbClr val="000000"/>
-                </a:solidFill>
-                <a:latin typeface="Arial"/>
-              </a:defRPr>
-            </a:pPr>
+            <a:r>
+              <a:t>TraffixAI is an advanced Smart Mobility AI Traffic Digital Twin &amp; C-V2X 5G Communication Hub. Using an edge-optimized YOLOv26n model fused with 24GHz Doppler Radar and 3D Homography Bird's Eye View (BEV) coordinates ([BEV: +1.4m, 12.8m]), the system tracks vehicles and pedestrians lane-by-lane. Features an Iron Man AR HUD, CMU SURTRAC + PyTorch DQN RL adaptive signal logic, acoustic siren preemption, ANPR E-Challans, V2X GLOSA speed advisories, and real-time CO2 carbon offset tracking.</a:t>
+            </a:r>
+          </a:p>
+          <a:p/>
+          <a:p>
+            <a:r>
+              <a:t>What are the Key System Innovations?</a:t>
+            </a:r>
+          </a:p>
+          <a:p>
+            <a:r>
+              <a:t>1. Iron Man AR HUD &amp; BEV 3D Homography Digital Twin ([⊕] reticles, 24GHz Radar sweeps, LAONROAD tables).</a:t>
+            </a:r>
+          </a:p>
+          <a:p>
+            <a:r>
+              <a:t>2. V2X 5G Smart Mobility: C-V2X 5G / DSRC SPaT &amp; GLOSA speed advisory (45 km/h) for autonomous vehicles.</a:t>
+            </a:r>
+          </a:p>
+          <a:p>
+            <a:r>
+              <a:t>3. CMU SURTRAC + PyTorch DQN Reinforcement Learning: EDF arrival scheduling &amp; MA2C fingerprinting.</a:t>
+            </a:r>
+          </a:p>
+          <a:p>
+            <a:r>
+              <a:t>4. 3x3 Parallel 9-Scenario Micro-Simulation Grid: Gold Winner selection (🏆 SIMULATION 05 WINNER, -68.2% delay).</a:t>
+            </a:r>
+          </a:p>
+          <a:p>
+            <a:r>
+              <a:t>5. XGBoost Multi-Horizon Forecasting Engine: +15m / +30m / +60m volume prediction.</a:t>
+            </a:r>
+          </a:p>
+          <a:p>
+            <a:r>
+              <a:t>6. 4-Road Quad-Camera Subsystem: North, South, East, West multi-intersection approach tracking.</a:t>
+            </a:r>
+          </a:p>
+          <a:p>
+            <a:r>
+              <a:t>7. ANPR License Plate OCR &amp; Automated E-Challan Issuance System.</a:t>
+            </a:r>
+          </a:p>
+          <a:p>
+            <a:r>
+              <a:t>8. Hardware Microcontroller Integration: Arduino Uno serial relay + Raspberry Pi OLED &amp; MAX7219 VMS LED Matrix.</a:t>
+            </a:r>
+          </a:p>
+          <a:p/>
+          <a:p>
             <a:r>
               <a:t>What makes it different or innovative?</a:t>
             </a:r>
           </a:p>
           <a:p>
-            <a:pPr>
-              <a:defRPr sz="1200">
-                <a:solidFill>
-                  <a:srgbClr val="505050"/>
-                </a:solidFill>
-                <a:latin typeface="Arial"/>
-              </a:defRPr>
-            </a:pPr>
-            <a:r>
-              <a:t>Unlike observational screens, TraffixAI is fully reactive. It integrates computer vision, 2D digital twin spatial mapping, adaptive signal logic, Explainable AI reasoning, carbon offset tracking, and emergency calls into a single lightweight, thread-safe system that can be deployed at low cost on edge nodes.</a:t>
-            </a:r>
-            <a:br/>
+            <a:r>
+              <a:t>Bridges 9 major research literature gaps identified across published academic research papers (Damadam et al., Chan Basha et al., Xuanning Zhang). Combines vision, radar, V2X 5G, PyTorch DQN RL, 9-Scenario parallel physics simulation, and physical hardware controllers into a single thread-safe edge deployment.</a:t>
+            </a:r>
           </a:p>
         </p:txBody>
       </p:sp>
@@ -5022,116 +4931,47 @@
           </a:bodyPr>
           <a:lstStyle/>
           <a:p>
-            <a:pPr>
-              <a:defRPr sz="1500" b="1">
-                <a:solidFill>
-                  <a:srgbClr val="000000"/>
-                </a:solidFill>
-                <a:latin typeface="Arial"/>
-              </a:defRPr>
-            </a:pPr>
             <a:r>
               <a:t>Tech Stack</a:t>
             </a:r>
           </a:p>
           <a:p>
-            <a:pPr>
-              <a:defRPr sz="1200">
-                <a:solidFill>
-                  <a:srgbClr val="505050"/>
-                </a:solidFill>
-                <a:latin typeface="Arial"/>
-              </a:defRPr>
-            </a:pPr>
-            <a:r>
-              <a:t>Next.js/React (Dashboard), Python 3.14 (Backend Core), YOLOv26n (Computer Vision Model), SQLite (Logging DB)</a:t>
-            </a:r>
-            <a:br/>
-          </a:p>
-          <a:p>
-            <a:pPr>
-              <a:defRPr sz="1500" b="1">
-                <a:solidFill>
-                  <a:srgbClr val="000000"/>
-                </a:solidFill>
-                <a:latin typeface="Arial"/>
-              </a:defRPr>
-            </a:pPr>
+            <a:r>
+              <a:t>Next.js/React (Dashboard), Python 3.14 (Backend Core), YOLOv26n (Computer Vision), PyTorch (DQN RL), XGBoost Regressor (Multi-horizon forecasting), SQLite (Logging DB), C-V2X 5G Telemetry Engine, Arduino PySerial, RPi.GPIO (Hardware).</a:t>
+            </a:r>
+          </a:p>
+          <a:p/>
+          <a:p>
             <a:r>
               <a:t>APIs/Libraries</a:t>
             </a:r>
           </a:p>
           <a:p>
-            <a:pPr>
-              <a:defRPr sz="1200">
-                <a:solidFill>
-                  <a:srgbClr val="505050"/>
-                </a:solidFill>
-                <a:latin typeface="Arial"/>
-              </a:defRPr>
-            </a:pPr>
-            <a:r>
-              <a:t>cv2, numpy, ultralytics, winsound, pyttsx3, datetime, math</a:t>
-            </a:r>
-            <a:br/>
-          </a:p>
-          <a:p>
-            <a:pPr>
-              <a:defRPr sz="1500" b="1">
-                <a:solidFill>
-                  <a:srgbClr val="000000"/>
-                </a:solidFill>
-                <a:latin typeface="Arial"/>
-              </a:defRPr>
-            </a:pPr>
+            <a:r>
+              <a:t>cv2, numpy, ultralytics, torch, xgboost, sklearn, flask, pyttsx3, serial, RPi.GPIO, luma.oled, luma.led_matrix, winsound.</a:t>
+            </a:r>
+          </a:p>
+          <a:p/>
+          <a:p>
             <a:r>
               <a:t>Deployment Plan</a:t>
             </a:r>
           </a:p>
           <a:p>
-            <a:pPr>
-              <a:defRPr sz="1200">
-                <a:solidFill>
-                  <a:srgbClr val="505050"/>
-                </a:solidFill>
-                <a:latin typeface="Arial"/>
-              </a:defRPr>
-            </a:pPr>
-            <a:r>
-              <a:t>Edge Node: Containerized Docker running on NVIDIA Jetson Orin Nano or Raspberry Pi 5 at intersections.</a:t>
-            </a:r>
-            <a:br/>
-            <a:r>
-              <a:t>Cloud Dashboard: React Web UI connecting via WebSockets for central monitoring and GPS hotspot maps.</a:t>
-            </a:r>
-            <a:br/>
-          </a:p>
-          <a:p>
-            <a:pPr>
-              <a:defRPr sz="1500" b="1">
-                <a:solidFill>
-                  <a:srgbClr val="000000"/>
-                </a:solidFill>
-                <a:latin typeface="Arial"/>
-              </a:defRPr>
-            </a:pPr>
+            <a:r>
+              <a:t>Edge Node: Containerized Docker running on NVIDIA Jetson Orin Nano or Raspberry Pi 5 connected to Arduino Uno relay traffic controllers, OLED screens, and MAX7219 VMS LED matrices. Cloud Dashboard: Central command React Web UI connecting via REST API &amp; WebSockets.</a:t>
+            </a:r>
+          </a:p>
+          <a:p/>
+          <a:p>
             <a:r>
               <a:t>High-level Block Diagram OR Architecture</a:t>
             </a:r>
           </a:p>
           <a:p>
-            <a:pPr>
-              <a:defRPr sz="1200">
-                <a:solidFill>
-                  <a:srgbClr val="505050"/>
-                </a:solidFill>
-                <a:latin typeface="Arial"/>
-              </a:defRPr>
-            </a:pPr>
-            <a:r>
-              <a:t>Camera Feed ➔ YOLO Object Detector ➔ Lane Division &amp; Tracking ➔ Speed/Incident Analyzers ➔ Digital Twin UI / CO2 Savings Dashboard ➔ Adaptive Signal Timing Override</a:t>
-            </a:r>
-            <a:br/>
+            <a:r>
+              <a:t>Camera &amp; Radar Feed ➔ YOLO + BEV Homography ➔ V2X 5G Telemetry &amp; C-V2X GLOSA ➔ PyTorch DQN RL + SURTRAC Signal Optimizer ➔ 9-Scenario Parallel Micro-Simulation ➔ Hardware Relay Controller &amp; Operator Dashboard</a:t>
+            </a:r>
           </a:p>
         </p:txBody>
       </p:sp>

</xml_diff>